<commit_message>
Restyle field status report with terracotta palette and goal rows
Co-Authored-By: Claude Opus 5.5 <noreply@anthropic.com>
Claude-Session: https://claude.ai/code/session_01Vb9vKaZFq6SXomdoRU57mW
</commit_message>
<xml_diff>
--- a/社員会議資料/2026年9月_現場状況報告と対策_神田.pptx
+++ b/社員会議資料/2026年9月_現場状況報告と対策_神田.pptx
@@ -113,12 +113,12 @@
   <p:extLst>
     <p:ext uri="{521415D9-36F7-43E2-AB2F-B90AF26B5E84}">
       <p14:sectionLst xmlns:p14="http://schemas.microsoft.com/office/powerpoint/2010/main">
-        <p14:section name="表紙" id="{c3c30287-9988-2674-5ef0-1d102c3154c4}">
+        <p14:section name="表紙" id="{1d883914-9fe0-3c42-21ac-291fcfe6fee2}">
           <p14:sldIdLst>
             <p14:sldId id="256"/>
           </p14:sldIdLst>
         </p14:section>
-        <p14:section name="現場状況" id="{8d8ca466-dccf-d957-db58-958ae2822631}">
+        <p14:section name="現場状況" id="{6bcec90e-3a57-9eb4-e259-52af24946923}">
           <p14:sldIdLst>
             <p14:sldId id="257"/>
             <p14:sldId id="258"/>
@@ -2942,11 +2942,11 @@
             <a:avLst/>
           </a:prstGeom>
           <a:solidFill>
-            <a:srgbClr val="F2F2F2"/>
+            <a:srgbClr val="F6F2EF"/>
           </a:solidFill>
           <a:ln w="12700">
             <a:solidFill>
-              <a:srgbClr val="F2F2F2"/>
+              <a:srgbClr val="F6F2EF"/>
             </a:solidFill>
             <a:prstDash val="solid"/>
           </a:ln>
@@ -3147,11 +3147,11 @@
             <a:avLst/>
           </a:prstGeom>
           <a:solidFill>
-            <a:schemeClr val="accent3"/>
+            <a:schemeClr val="accent1"/>
           </a:solidFill>
           <a:ln w="12700">
             <a:solidFill>
-              <a:schemeClr val="accent3"/>
+              <a:schemeClr val="accent1"/>
             </a:solidFill>
             <a:prstDash val="solid"/>
           </a:ln>
@@ -3413,11 +3413,11 @@
             <a:avLst/>
           </a:prstGeom>
           <a:solidFill>
-            <a:schemeClr val="accent3"/>
+            <a:schemeClr val="accent1"/>
           </a:solidFill>
           <a:ln w="12700">
             <a:solidFill>
-              <a:schemeClr val="accent3"/>
+              <a:schemeClr val="accent1"/>
             </a:solidFill>
             <a:prstDash val="solid"/>
           </a:ln>
@@ -3474,11 +3474,11 @@
             <a:avLst/>
           </a:prstGeom>
           <a:solidFill>
-            <a:srgbClr val="F2F2F2"/>
+            <a:srgbClr val="F6F2EF"/>
           </a:solidFill>
           <a:ln w="12700">
             <a:solidFill>
-              <a:srgbClr val="F2F2F2"/>
+              <a:srgbClr val="F6F2EF"/>
             </a:solidFill>
             <a:prstDash val="solid"/>
           </a:ln>
@@ -3945,11 +3945,11 @@
             <a:avLst/>
           </a:prstGeom>
           <a:solidFill>
-            <a:schemeClr val="accent3"/>
+            <a:schemeClr val="accent1"/>
           </a:solidFill>
           <a:ln w="12700">
             <a:solidFill>
-              <a:schemeClr val="accent3"/>
+              <a:schemeClr val="accent1"/>
             </a:solidFill>
             <a:prstDash val="solid"/>
           </a:ln>
@@ -4299,11 +4299,11 @@
             <a:avLst/>
           </a:prstGeom>
           <a:solidFill>
-            <a:srgbClr val="F2F2F2"/>
+            <a:srgbClr val="F6F2EF"/>
           </a:solidFill>
           <a:ln w="12700">
             <a:solidFill>
-              <a:srgbClr val="F2F2F2"/>
+              <a:srgbClr val="F6F2EF"/>
             </a:solidFill>
             <a:prstDash val="solid"/>
           </a:ln>
@@ -4560,11 +4560,11 @@
             <a:avLst/>
           </a:prstGeom>
           <a:solidFill>
-            <a:srgbClr val="F2F2F2"/>
+            <a:srgbClr val="F6F2EF"/>
           </a:solidFill>
           <a:ln w="12700">
             <a:solidFill>
-              <a:srgbClr val="F2F2F2"/>
+              <a:srgbClr val="F6F2EF"/>
             </a:solidFill>
             <a:prstDash val="solid"/>
           </a:ln>
@@ -4934,7 +4934,7 @@
           <a:noFill/>
           <a:ln w="15875">
             <a:solidFill>
-              <a:srgbClr val="2F5D50"/>
+              <a:srgbClr val="B5532F"/>
             </a:solidFill>
             <a:prstDash val="solid"/>
           </a:ln>
@@ -5438,7 +5438,7 @@
         </p:nvSpPr>
         <p:spPr>
           <a:xfrm>
-            <a:off x="3794760" y="2953512"/>
+            <a:off x="3794760" y="2724912"/>
             <a:ext cx="2286000" cy="274320"/>
           </a:xfrm>
           <a:prstGeom prst="rect">
@@ -5475,17 +5475,17 @@
         <p:spPr>
           <a:xfrm>
             <a:off x="3794760" y="1097280"/>
-            <a:ext cx="2433218" cy="1828800"/>
+            <a:ext cx="2433218" cy="1600200"/>
           </a:xfrm>
           <a:prstGeom prst="rect">
             <a:avLst/>
           </a:prstGeom>
           <a:solidFill>
-            <a:srgbClr val="F2F2F2"/>
+            <a:srgbClr val="F6F2EF"/>
           </a:solidFill>
           <a:ln w="12700">
             <a:solidFill>
-              <a:srgbClr val="F2F2F2"/>
+              <a:srgbClr val="F6F2EF"/>
             </a:solidFill>
             <a:prstDash val="solid"/>
           </a:ln>
@@ -5499,143 +5499,10 @@
         </p:nvSpPr>
         <p:spPr>
           <a:xfrm>
-            <a:off x="4023360" y="2468880"/>
-            <a:ext cx="640080" cy="274320"/>
-          </a:xfrm>
-          <a:prstGeom prst="rect">
-            <a:avLst/>
-          </a:prstGeom>
-          <a:solidFill>
-            <a:schemeClr val="accent3"/>
-          </a:solidFill>
-          <a:ln w="12700">
-            <a:solidFill>
-              <a:schemeClr val="accent3"/>
-            </a:solidFill>
-            <a:prstDash val="solid"/>
-          </a:ln>
-        </p:spPr>
-      </p:sp>
-      <p:sp>
-        <p:nvSpPr>
-          <p:cNvPr id="10" name="t-80"/>
-          <p:cNvSpPr txBox="1"/>
-          <p:nvPr/>
-        </p:nvSpPr>
-        <p:spPr>
-          <a:xfrm>
-            <a:off x="4023360" y="2468880"/>
-            <a:ext cx="640080" cy="274320"/>
-          </a:xfrm>
-          <a:prstGeom prst="rect">
-            <a:avLst/>
-          </a:prstGeom>
-          <a:noFill/>
-          <a:ln/>
-        </p:spPr>
-        <p:txBody>
-          <a:bodyPr wrap="square" lIns="0" tIns="0" rIns="0" bIns="0" rtlCol="0" anchor="ctr"/>
-          <a:lstStyle/>
-          <a:p>
-            <a:pPr algn="ctr" indent="0" marL="0">
-              <a:buNone/>
-            </a:pPr>
-            <a:r>
-              <a:rPr lang="en-US" sz="1000" b="1" dirty="0">
-                <a:solidFill>
-                  <a:schemeClr val="bg1"/>
-                </a:solidFill>
-              </a:rPr>
-              <a:t>最優先</a:t>
-            </a:r>
-            <a:endParaRPr lang="en-US" sz="1000" dirty="0"/>
-          </a:p>
-        </p:txBody>
-      </p:sp>
-      <p:sp>
-        <p:nvSpPr>
-          <p:cNvPr id="11" name="t-81"/>
-          <p:cNvSpPr txBox="1"/>
-          <p:nvPr/>
-        </p:nvSpPr>
-        <p:spPr>
-          <a:xfrm>
-            <a:off x="4023360" y="1280160"/>
-            <a:ext cx="2067458" cy="685800"/>
-          </a:xfrm>
-          <a:prstGeom prst="rect">
-            <a:avLst/>
-          </a:prstGeom>
-          <a:noFill/>
-          <a:ln/>
-        </p:spPr>
-        <p:txBody>
-          <a:bodyPr wrap="square" lIns="0" tIns="0" rIns="0" bIns="0" rtlCol="0" anchor="t"/>
-          <a:lstStyle/>
-          <a:p>
-            <a:pPr indent="0" marL="0">
-              <a:buNone/>
-            </a:pPr>
-            <a:r>
-              <a:rPr lang="en-US" sz="1500" b="1" dirty="0">
-                <a:solidFill>
-                  <a:schemeClr val="tx1"/>
-                </a:solidFill>
-              </a:rPr>
-              <a:t>週末の人手不足</a:t>
-            </a:r>
-            <a:endParaRPr lang="en-US" sz="1500" dirty="0"/>
-          </a:p>
-        </p:txBody>
-      </p:sp>
-      <p:sp>
-        <p:nvSpPr>
-          <p:cNvPr id="12" name="t-82"/>
-          <p:cNvSpPr txBox="1"/>
-          <p:nvPr/>
-        </p:nvSpPr>
-        <p:spPr>
-          <a:xfrm>
-            <a:off x="4023360" y="1737360"/>
-            <a:ext cx="2021738" cy="685800"/>
-          </a:xfrm>
-          <a:prstGeom prst="rect">
-            <a:avLst/>
-          </a:prstGeom>
-          <a:noFill/>
-          <a:ln/>
-        </p:spPr>
-        <p:txBody>
-          <a:bodyPr wrap="square" lIns="0" tIns="0" rIns="0" bIns="0" rtlCol="0" anchor="t"/>
-          <a:lstStyle/>
-          <a:p>
-            <a:pPr indent="0" marL="0">
-              <a:buNone/>
-            </a:pPr>
-            <a:r>
-              <a:rPr lang="en-US" sz="1200" dirty="0">
-                <a:solidFill>
-                  <a:schemeClr val="tx2"/>
-                </a:solidFill>
-              </a:rPr>
-              <a:t>毎月ひどくなっている</a:t>
-            </a:r>
-            <a:endParaRPr lang="en-US" sz="1200" dirty="0"/>
-          </a:p>
-        </p:txBody>
-      </p:sp>
-      <p:sp>
-        <p:nvSpPr>
-          <p:cNvPr id="13" name="arrow-83"/>
-          <p:cNvSpPr/>
-          <p:nvPr/>
-        </p:nvSpPr>
-        <p:spPr>
-          <a:xfrm rot="10800000">
-            <a:off x="4855921" y="3017520"/>
-            <a:ext cx="310896" cy="201168"/>
-          </a:xfrm>
-          <a:prstGeom prst="triangle">
+            <a:off x="5569610" y="1298448"/>
+            <a:ext cx="548640" cy="256032"/>
+          </a:xfrm>
+          <a:prstGeom prst="rect">
             <a:avLst/>
           </a:prstGeom>
           <a:solidFill>
@@ -5651,14 +5518,147 @@
       </p:sp>
       <p:sp>
         <p:nvSpPr>
+          <p:cNvPr id="10" name="t-80"/>
+          <p:cNvSpPr txBox="1"/>
+          <p:nvPr/>
+        </p:nvSpPr>
+        <p:spPr>
+          <a:xfrm>
+            <a:off x="5569610" y="1298448"/>
+            <a:ext cx="548640" cy="256032"/>
+          </a:xfrm>
+          <a:prstGeom prst="rect">
+            <a:avLst/>
+          </a:prstGeom>
+          <a:noFill/>
+          <a:ln/>
+        </p:spPr>
+        <p:txBody>
+          <a:bodyPr wrap="square" lIns="0" tIns="0" rIns="0" bIns="0" rtlCol="0" anchor="ctr"/>
+          <a:lstStyle/>
+          <a:p>
+            <a:pPr algn="ctr" indent="0" marL="0">
+              <a:buNone/>
+            </a:pPr>
+            <a:r>
+              <a:rPr lang="en-US" sz="900" b="1" dirty="0">
+                <a:solidFill>
+                  <a:schemeClr val="bg1"/>
+                </a:solidFill>
+              </a:rPr>
+              <a:t>最優先</a:t>
+            </a:r>
+            <a:endParaRPr lang="en-US" sz="900" dirty="0"/>
+          </a:p>
+        </p:txBody>
+      </p:sp>
+      <p:sp>
+        <p:nvSpPr>
+          <p:cNvPr id="11" name="t-81"/>
+          <p:cNvSpPr txBox="1"/>
+          <p:nvPr/>
+        </p:nvSpPr>
+        <p:spPr>
+          <a:xfrm>
+            <a:off x="4023360" y="1280160"/>
+            <a:ext cx="1518818" cy="411480"/>
+          </a:xfrm>
+          <a:prstGeom prst="rect">
+            <a:avLst/>
+          </a:prstGeom>
+          <a:noFill/>
+          <a:ln/>
+        </p:spPr>
+        <p:txBody>
+          <a:bodyPr wrap="square" lIns="0" tIns="0" rIns="0" bIns="0" rtlCol="0" anchor="t"/>
+          <a:lstStyle/>
+          <a:p>
+            <a:pPr indent="0" marL="0">
+              <a:buNone/>
+            </a:pPr>
+            <a:r>
+              <a:rPr lang="en-US" sz="1500" b="1" dirty="0">
+                <a:solidFill>
+                  <a:schemeClr val="tx1"/>
+                </a:solidFill>
+              </a:rPr>
+              <a:t>週末の人手不足</a:t>
+            </a:r>
+            <a:endParaRPr lang="en-US" sz="1500" dirty="0"/>
+          </a:p>
+        </p:txBody>
+      </p:sp>
+      <p:sp>
+        <p:nvSpPr>
+          <p:cNvPr id="12" name="t-82"/>
+          <p:cNvSpPr txBox="1"/>
+          <p:nvPr/>
+        </p:nvSpPr>
+        <p:spPr>
+          <a:xfrm>
+            <a:off x="4023360" y="1737360"/>
+            <a:ext cx="2021738" cy="457200"/>
+          </a:xfrm>
+          <a:prstGeom prst="rect">
+            <a:avLst/>
+          </a:prstGeom>
+          <a:noFill/>
+          <a:ln/>
+        </p:spPr>
+        <p:txBody>
+          <a:bodyPr wrap="square" lIns="0" tIns="0" rIns="0" bIns="0" rtlCol="0" anchor="t"/>
+          <a:lstStyle/>
+          <a:p>
+            <a:pPr indent="0" marL="0">
+              <a:buNone/>
+            </a:pPr>
+            <a:r>
+              <a:rPr lang="en-US" sz="1200" dirty="0">
+                <a:solidFill>
+                  <a:schemeClr val="tx2"/>
+                </a:solidFill>
+              </a:rPr>
+              <a:t>毎月ひどくなっている</a:t>
+            </a:r>
+            <a:endParaRPr lang="en-US" sz="1200" dirty="0"/>
+          </a:p>
+        </p:txBody>
+      </p:sp>
+      <p:sp>
+        <p:nvSpPr>
+          <p:cNvPr id="13" name="arrow-83"/>
+          <p:cNvSpPr/>
+          <p:nvPr/>
+        </p:nvSpPr>
+        <p:spPr>
+          <a:xfrm rot="10800000">
+            <a:off x="4855921" y="2788920"/>
+            <a:ext cx="310896" cy="201168"/>
+          </a:xfrm>
+          <a:prstGeom prst="triangle">
+            <a:avLst/>
+          </a:prstGeom>
+          <a:solidFill>
+            <a:schemeClr val="accent1"/>
+          </a:solidFill>
+          <a:ln w="12700">
+            <a:solidFill>
+              <a:schemeClr val="accent1"/>
+            </a:solidFill>
+            <a:prstDash val="solid"/>
+          </a:ln>
+        </p:spPr>
+      </p:sp>
+      <p:sp>
+        <p:nvSpPr>
           <p:cNvPr id="14" name="act-bg-84"/>
           <p:cNvSpPr/>
           <p:nvPr/>
         </p:nvSpPr>
         <p:spPr>
           <a:xfrm>
-            <a:off x="3794760" y="3337560"/>
-            <a:ext cx="2433218" cy="2514600"/>
+            <a:off x="3794760" y="3108960"/>
+            <a:ext cx="2433218" cy="2011680"/>
           </a:xfrm>
           <a:prstGeom prst="rect">
             <a:avLst/>
@@ -5682,7 +5682,7 @@
         </p:nvSpPr>
         <p:spPr>
           <a:xfrm>
-            <a:off x="4023360" y="3520440"/>
+            <a:off x="4023360" y="3291840"/>
             <a:ext cx="2067458" cy="685800"/>
           </a:xfrm>
           <a:prstGeom prst="rect">
@@ -5718,8 +5718,8 @@
         </p:nvSpPr>
         <p:spPr>
           <a:xfrm>
-            <a:off x="4023360" y="4023360"/>
-            <a:ext cx="2021738" cy="1691640"/>
+            <a:off x="4023360" y="3794760"/>
+            <a:ext cx="2021738" cy="1188720"/>
           </a:xfrm>
           <a:prstGeom prst="rect">
             <a:avLst/>
@@ -5777,17 +5777,17 @@
         <p:spPr>
           <a:xfrm>
             <a:off x="6502298" y="1097280"/>
-            <a:ext cx="2433218" cy="1828800"/>
+            <a:ext cx="2433218" cy="1600200"/>
           </a:xfrm>
           <a:prstGeom prst="rect">
             <a:avLst/>
           </a:prstGeom>
           <a:solidFill>
-            <a:srgbClr val="F2F2F2"/>
+            <a:srgbClr val="F6F2EF"/>
           </a:solidFill>
           <a:ln w="12700">
             <a:solidFill>
-              <a:srgbClr val="F2F2F2"/>
+              <a:srgbClr val="F6F2EF"/>
             </a:solidFill>
             <a:prstDash val="solid"/>
           </a:ln>
@@ -5802,7 +5802,7 @@
         <p:spPr>
           <a:xfrm>
             <a:off x="6730898" y="1280160"/>
-            <a:ext cx="2067458" cy="685800"/>
+            <a:ext cx="2067458" cy="411480"/>
           </a:xfrm>
           <a:prstGeom prst="rect">
             <a:avLst/>
@@ -5838,7 +5838,7 @@
         <p:spPr>
           <a:xfrm>
             <a:off x="6730898" y="1737360"/>
-            <a:ext cx="2021738" cy="685800"/>
+            <a:ext cx="2021738" cy="457200"/>
           </a:xfrm>
           <a:prstGeom prst="rect">
             <a:avLst/>
@@ -5873,7 +5873,7 @@
         </p:nvSpPr>
         <p:spPr>
           <a:xfrm rot="10800000">
-            <a:off x="7563460" y="3017520"/>
+            <a:off x="7563460" y="2788920"/>
             <a:ext cx="310896" cy="201168"/>
           </a:xfrm>
           <a:prstGeom prst="triangle">
@@ -5898,8 +5898,8 @@
         </p:nvSpPr>
         <p:spPr>
           <a:xfrm>
-            <a:off x="6502298" y="3337560"/>
-            <a:ext cx="2433218" cy="2514600"/>
+            <a:off x="6502298" y="3108960"/>
+            <a:ext cx="2433218" cy="2011680"/>
           </a:xfrm>
           <a:prstGeom prst="rect">
             <a:avLst/>
@@ -5923,7 +5923,7 @@
         </p:nvSpPr>
         <p:spPr>
           <a:xfrm>
-            <a:off x="6730898" y="3520440"/>
+            <a:off x="6730898" y="3291840"/>
             <a:ext cx="2067458" cy="685800"/>
           </a:xfrm>
           <a:prstGeom prst="rect">
@@ -5959,8 +5959,8 @@
         </p:nvSpPr>
         <p:spPr>
           <a:xfrm>
-            <a:off x="6730898" y="4023360"/>
-            <a:ext cx="2021738" cy="1691640"/>
+            <a:off x="6730898" y="3794760"/>
+            <a:ext cx="2021738" cy="1188720"/>
           </a:xfrm>
           <a:prstGeom prst="rect">
             <a:avLst/>
@@ -6018,17 +6018,17 @@
         <p:spPr>
           <a:xfrm>
             <a:off x="9209837" y="1097280"/>
-            <a:ext cx="2433218" cy="1828800"/>
+            <a:ext cx="2433218" cy="1600200"/>
           </a:xfrm>
           <a:prstGeom prst="rect">
             <a:avLst/>
           </a:prstGeom>
           <a:solidFill>
-            <a:srgbClr val="F2F2F2"/>
+            <a:srgbClr val="F6F2EF"/>
           </a:solidFill>
           <a:ln w="12700">
             <a:solidFill>
-              <a:srgbClr val="F2F2F2"/>
+              <a:srgbClr val="F6F2EF"/>
             </a:solidFill>
             <a:prstDash val="solid"/>
           </a:ln>
@@ -6043,7 +6043,7 @@
         <p:spPr>
           <a:xfrm>
             <a:off x="9438437" y="1280160"/>
-            <a:ext cx="2067458" cy="685800"/>
+            <a:ext cx="2067458" cy="411480"/>
           </a:xfrm>
           <a:prstGeom prst="rect">
             <a:avLst/>
@@ -6079,7 +6079,7 @@
         <p:spPr>
           <a:xfrm>
             <a:off x="9438437" y="1737360"/>
-            <a:ext cx="2021738" cy="685800"/>
+            <a:ext cx="2021738" cy="457200"/>
           </a:xfrm>
           <a:prstGeom prst="rect">
             <a:avLst/>
@@ -6114,7 +6114,7 @@
         </p:nvSpPr>
         <p:spPr>
           <a:xfrm rot="10800000">
-            <a:off x="10270998" y="3017520"/>
+            <a:off x="10270998" y="2788920"/>
             <a:ext cx="310896" cy="201168"/>
           </a:xfrm>
           <a:prstGeom prst="triangle">
@@ -6139,8 +6139,8 @@
         </p:nvSpPr>
         <p:spPr>
           <a:xfrm>
-            <a:off x="9209837" y="3337560"/>
-            <a:ext cx="2433218" cy="2514600"/>
+            <a:off x="9209837" y="3108960"/>
+            <a:ext cx="2433218" cy="2011680"/>
           </a:xfrm>
           <a:prstGeom prst="rect">
             <a:avLst/>
@@ -6164,7 +6164,7 @@
         </p:nvSpPr>
         <p:spPr>
           <a:xfrm>
-            <a:off x="9438437" y="3520440"/>
+            <a:off x="9438437" y="3291840"/>
             <a:ext cx="2067458" cy="685800"/>
           </a:xfrm>
           <a:prstGeom prst="rect">
@@ -6200,8 +6200,8 @@
         </p:nvSpPr>
         <p:spPr>
           <a:xfrm>
-            <a:off x="9438437" y="4023360"/>
-            <a:ext cx="2021738" cy="1691640"/>
+            <a:off x="9438437" y="3794760"/>
+            <a:ext cx="2021738" cy="1188720"/>
           </a:xfrm>
           <a:prstGeom prst="rect">
             <a:avLst/>
@@ -6265,6 +6265,101 @@
               <a:t>平日の落ち着いた時間にOJT</a:t>
             </a:r>
             <a:endParaRPr lang="en-US" sz="1200" dirty="0"/>
+          </a:p>
+        </p:txBody>
+      </p:sp>
+      <p:sp>
+        <p:nvSpPr>
+          <p:cNvPr id="31" name="rule-101"/>
+          <p:cNvSpPr/>
+          <p:nvPr/>
+        </p:nvSpPr>
+        <p:spPr>
+          <a:xfrm>
+            <a:off x="3794760" y="5394960"/>
+            <a:ext cx="7848295" cy="0"/>
+          </a:xfrm>
+          <a:prstGeom prst="line">
+            <a:avLst/>
+          </a:prstGeom>
+          <a:noFill/>
+          <a:ln w="9525">
+            <a:solidFill>
+              <a:srgbClr val="E3DCD6"/>
+            </a:solidFill>
+            <a:prstDash val="solid"/>
+          </a:ln>
+        </p:spPr>
+      </p:sp>
+      <p:sp>
+        <p:nvSpPr>
+          <p:cNvPr id="32" name="t-102"/>
+          <p:cNvSpPr txBox="1"/>
+          <p:nvPr/>
+        </p:nvSpPr>
+        <p:spPr>
+          <a:xfrm>
+            <a:off x="3794760" y="5504688"/>
+            <a:ext cx="1371600" cy="411480"/>
+          </a:xfrm>
+          <a:prstGeom prst="rect">
+            <a:avLst/>
+          </a:prstGeom>
+          <a:noFill/>
+          <a:ln/>
+        </p:spPr>
+        <p:txBody>
+          <a:bodyPr wrap="square" lIns="0" tIns="0" rIns="0" bIns="0" rtlCol="0" anchor="ctr"/>
+          <a:lstStyle/>
+          <a:p>
+            <a:pPr indent="0" marL="0">
+              <a:buNone/>
+            </a:pPr>
+            <a:r>
+              <a:rPr lang="en-US" sz="1300" b="1" dirty="0">
+                <a:solidFill>
+                  <a:schemeClr val="accent3"/>
+                </a:solidFill>
+              </a:rPr>
+              <a:t>目指す状態</a:t>
+            </a:r>
+            <a:endParaRPr lang="en-US" sz="1300" dirty="0"/>
+          </a:p>
+        </p:txBody>
+      </p:sp>
+      <p:sp>
+        <p:nvSpPr>
+          <p:cNvPr id="33" name="t-103"/>
+          <p:cNvSpPr txBox="1"/>
+          <p:nvPr/>
+        </p:nvSpPr>
+        <p:spPr>
+          <a:xfrm>
+            <a:off x="5212080" y="5504688"/>
+            <a:ext cx="6430975" cy="411480"/>
+          </a:xfrm>
+          <a:prstGeom prst="rect">
+            <a:avLst/>
+          </a:prstGeom>
+          <a:noFill/>
+          <a:ln/>
+        </p:spPr>
+        <p:txBody>
+          <a:bodyPr wrap="square" lIns="0" tIns="0" rIns="0" bIns="0" rtlCol="0" anchor="ctr"/>
+          <a:lstStyle/>
+          <a:p>
+            <a:pPr indent="0" marL="0">
+              <a:buNone/>
+            </a:pPr>
+            <a:r>
+              <a:rPr lang="en-US" sz="1400" b="1" dirty="0">
+                <a:solidFill>
+                  <a:schemeClr val="tx1"/>
+                </a:solidFill>
+              </a:rPr>
+              <a:t>週末を含め、毎日リーダー1名と必要人数がそろうシフト</a:t>
+            </a:r>
+            <a:endParaRPr lang="en-US" sz="1400" dirty="0"/>
           </a:p>
         </p:txBody>
       </p:sp>
@@ -6491,7 +6586,7 @@
       </p:sp>
       <p:sp>
         <p:nvSpPr>
-          <p:cNvPr id="6" name="t-101"/>
+          <p:cNvPr id="6" name="t-104"/>
           <p:cNvSpPr txBox="1"/>
           <p:nvPr/>
         </p:nvSpPr>
@@ -6527,13 +6622,13 @@
       </p:sp>
       <p:sp>
         <p:nvSpPr>
-          <p:cNvPr id="7" name="t-102"/>
-          <p:cNvSpPr txBox="1"/>
-          <p:nvPr/>
-        </p:nvSpPr>
-        <p:spPr>
-          <a:xfrm>
-            <a:off x="3794760" y="2953512"/>
+          <p:cNvPr id="7" name="t-105"/>
+          <p:cNvSpPr txBox="1"/>
+          <p:nvPr/>
+        </p:nvSpPr>
+        <p:spPr>
+          <a:xfrm>
+            <a:off x="3794760" y="2724912"/>
             <a:ext cx="2286000" cy="274320"/>
           </a:xfrm>
           <a:prstGeom prst="rect">
@@ -6563,24 +6658,24 @@
       </p:sp>
       <p:sp>
         <p:nvSpPr>
-          <p:cNvPr id="8" name="issue-bg-103"/>
+          <p:cNvPr id="8" name="issue-bg-106"/>
           <p:cNvSpPr/>
           <p:nvPr/>
         </p:nvSpPr>
         <p:spPr>
           <a:xfrm>
             <a:off x="3794760" y="1097280"/>
-            <a:ext cx="3786988" cy="1828800"/>
+            <a:ext cx="3786988" cy="1600200"/>
           </a:xfrm>
           <a:prstGeom prst="rect">
             <a:avLst/>
           </a:prstGeom>
           <a:solidFill>
-            <a:srgbClr val="F2F2F2"/>
+            <a:srgbClr val="F6F2EF"/>
           </a:solidFill>
           <a:ln w="12700">
             <a:solidFill>
-              <a:srgbClr val="F2F2F2"/>
+              <a:srgbClr val="F6F2EF"/>
             </a:solidFill>
             <a:prstDash val="solid"/>
           </a:ln>
@@ -6588,14 +6683,14 @@
       </p:sp>
       <p:sp>
         <p:nvSpPr>
-          <p:cNvPr id="9" name="t-104"/>
+          <p:cNvPr id="9" name="t-107"/>
           <p:cNvSpPr txBox="1"/>
           <p:nvPr/>
         </p:nvSpPr>
         <p:spPr>
           <a:xfrm>
             <a:off x="4023360" y="1280160"/>
-            <a:ext cx="3421228" cy="685800"/>
+            <a:ext cx="3421228" cy="411480"/>
           </a:xfrm>
           <a:prstGeom prst="rect">
             <a:avLst/>
@@ -6624,14 +6719,14 @@
       </p:sp>
       <p:sp>
         <p:nvSpPr>
-          <p:cNvPr id="10" name="t-105"/>
+          <p:cNvPr id="10" name="t-108"/>
           <p:cNvSpPr txBox="1"/>
           <p:nvPr/>
         </p:nvSpPr>
         <p:spPr>
           <a:xfrm>
             <a:off x="4023360" y="1737360"/>
-            <a:ext cx="3375508" cy="685800"/>
+            <a:ext cx="3375508" cy="457200"/>
           </a:xfrm>
           <a:prstGeom prst="rect">
             <a:avLst/>
@@ -6660,13 +6755,13 @@
       </p:sp>
       <p:sp>
         <p:nvSpPr>
-          <p:cNvPr id="11" name="arrow-106"/>
+          <p:cNvPr id="11" name="arrow-109"/>
           <p:cNvSpPr/>
           <p:nvPr/>
         </p:nvSpPr>
         <p:spPr>
           <a:xfrm rot="10800000">
-            <a:off x="5532806" y="3017520"/>
+            <a:off x="5532806" y="2788920"/>
             <a:ext cx="310896" cy="201168"/>
           </a:xfrm>
           <a:prstGeom prst="triangle">
@@ -6685,14 +6780,14 @@
       </p:sp>
       <p:sp>
         <p:nvSpPr>
-          <p:cNvPr id="12" name="act-bg-107"/>
+          <p:cNvPr id="12" name="act-bg-110"/>
           <p:cNvSpPr/>
           <p:nvPr/>
         </p:nvSpPr>
         <p:spPr>
           <a:xfrm>
-            <a:off x="3794760" y="3337560"/>
-            <a:ext cx="3786988" cy="2514600"/>
+            <a:off x="3794760" y="3108960"/>
+            <a:ext cx="3786988" cy="2011680"/>
           </a:xfrm>
           <a:prstGeom prst="rect">
             <a:avLst/>
@@ -6710,13 +6805,13 @@
       </p:sp>
       <p:sp>
         <p:nvSpPr>
-          <p:cNvPr id="13" name="t-108"/>
-          <p:cNvSpPr txBox="1"/>
-          <p:nvPr/>
-        </p:nvSpPr>
-        <p:spPr>
-          <a:xfrm>
-            <a:off x="4023360" y="3520440"/>
+          <p:cNvPr id="13" name="t-111"/>
+          <p:cNvSpPr txBox="1"/>
+          <p:nvPr/>
+        </p:nvSpPr>
+        <p:spPr>
+          <a:xfrm>
+            <a:off x="4023360" y="3291840"/>
             <a:ext cx="3421228" cy="685800"/>
           </a:xfrm>
           <a:prstGeom prst="rect">
@@ -6746,14 +6841,14 @@
       </p:sp>
       <p:sp>
         <p:nvSpPr>
-          <p:cNvPr id="14" name="t-109"/>
-          <p:cNvSpPr txBox="1"/>
-          <p:nvPr/>
-        </p:nvSpPr>
-        <p:spPr>
-          <a:xfrm>
-            <a:off x="4023360" y="4023360"/>
-            <a:ext cx="3375508" cy="1691640"/>
+          <p:cNvPr id="14" name="t-112"/>
+          <p:cNvSpPr txBox="1"/>
+          <p:nvPr/>
+        </p:nvSpPr>
+        <p:spPr>
+          <a:xfrm>
+            <a:off x="4023360" y="3794760"/>
+            <a:ext cx="3375508" cy="1188720"/>
           </a:xfrm>
           <a:prstGeom prst="rect">
             <a:avLst/>
@@ -6822,24 +6917,24 @@
       </p:sp>
       <p:sp>
         <p:nvSpPr>
-          <p:cNvPr id="15" name="issue-bg-110"/>
+          <p:cNvPr id="15" name="issue-bg-113"/>
           <p:cNvSpPr/>
           <p:nvPr/>
         </p:nvSpPr>
         <p:spPr>
           <a:xfrm>
             <a:off x="7856068" y="1097280"/>
-            <a:ext cx="3786988" cy="1828800"/>
+            <a:ext cx="3786988" cy="1600200"/>
           </a:xfrm>
           <a:prstGeom prst="rect">
             <a:avLst/>
           </a:prstGeom>
           <a:solidFill>
-            <a:srgbClr val="F2F2F2"/>
+            <a:srgbClr val="F6F2EF"/>
           </a:solidFill>
           <a:ln w="12700">
             <a:solidFill>
-              <a:srgbClr val="F2F2F2"/>
+              <a:srgbClr val="F6F2EF"/>
             </a:solidFill>
             <a:prstDash val="solid"/>
           </a:ln>
@@ -6847,14 +6942,14 @@
       </p:sp>
       <p:sp>
         <p:nvSpPr>
-          <p:cNvPr id="16" name="t-111"/>
+          <p:cNvPr id="16" name="t-114"/>
           <p:cNvSpPr txBox="1"/>
           <p:nvPr/>
         </p:nvSpPr>
         <p:spPr>
           <a:xfrm>
             <a:off x="8084668" y="1280160"/>
-            <a:ext cx="3421228" cy="685800"/>
+            <a:ext cx="3421228" cy="411480"/>
           </a:xfrm>
           <a:prstGeom prst="rect">
             <a:avLst/>
@@ -6883,14 +6978,14 @@
       </p:sp>
       <p:sp>
         <p:nvSpPr>
-          <p:cNvPr id="17" name="t-112"/>
+          <p:cNvPr id="17" name="t-115"/>
           <p:cNvSpPr txBox="1"/>
           <p:nvPr/>
         </p:nvSpPr>
         <p:spPr>
           <a:xfrm>
             <a:off x="8084668" y="1737360"/>
-            <a:ext cx="3375508" cy="685800"/>
+            <a:ext cx="3375508" cy="457200"/>
           </a:xfrm>
           <a:prstGeom prst="rect">
             <a:avLst/>
@@ -6919,13 +7014,13 @@
       </p:sp>
       <p:sp>
         <p:nvSpPr>
-          <p:cNvPr id="18" name="arrow-113"/>
+          <p:cNvPr id="18" name="arrow-116"/>
           <p:cNvSpPr/>
           <p:nvPr/>
         </p:nvSpPr>
         <p:spPr>
           <a:xfrm rot="10800000">
-            <a:off x="9594113" y="3017520"/>
+            <a:off x="9594113" y="2788920"/>
             <a:ext cx="310896" cy="201168"/>
           </a:xfrm>
           <a:prstGeom prst="triangle">
@@ -6944,14 +7039,14 @@
       </p:sp>
       <p:sp>
         <p:nvSpPr>
-          <p:cNvPr id="19" name="act-bg-114"/>
+          <p:cNvPr id="19" name="act-bg-117"/>
           <p:cNvSpPr/>
           <p:nvPr/>
         </p:nvSpPr>
         <p:spPr>
           <a:xfrm>
-            <a:off x="7856068" y="3337560"/>
-            <a:ext cx="3786988" cy="2514600"/>
+            <a:off x="7856068" y="3108960"/>
+            <a:ext cx="3786988" cy="2011680"/>
           </a:xfrm>
           <a:prstGeom prst="rect">
             <a:avLst/>
@@ -6969,13 +7064,13 @@
       </p:sp>
       <p:sp>
         <p:nvSpPr>
-          <p:cNvPr id="20" name="t-115"/>
-          <p:cNvSpPr txBox="1"/>
-          <p:nvPr/>
-        </p:nvSpPr>
-        <p:spPr>
-          <a:xfrm>
-            <a:off x="8084668" y="3520440"/>
+          <p:cNvPr id="20" name="t-118"/>
+          <p:cNvSpPr txBox="1"/>
+          <p:nvPr/>
+        </p:nvSpPr>
+        <p:spPr>
+          <a:xfrm>
+            <a:off x="8084668" y="3291840"/>
             <a:ext cx="3421228" cy="685800"/>
           </a:xfrm>
           <a:prstGeom prst="rect">
@@ -7005,14 +7100,14 @@
       </p:sp>
       <p:sp>
         <p:nvSpPr>
-          <p:cNvPr id="21" name="t-116"/>
-          <p:cNvSpPr txBox="1"/>
-          <p:nvPr/>
-        </p:nvSpPr>
-        <p:spPr>
-          <a:xfrm>
-            <a:off x="8084668" y="4023360"/>
-            <a:ext cx="3375508" cy="1691640"/>
+          <p:cNvPr id="21" name="t-119"/>
+          <p:cNvSpPr txBox="1"/>
+          <p:nvPr/>
+        </p:nvSpPr>
+        <p:spPr>
+          <a:xfrm>
+            <a:off x="8084668" y="3794760"/>
+            <a:ext cx="3375508" cy="1188720"/>
           </a:xfrm>
           <a:prstGeom prst="rect">
             <a:avLst/>
@@ -7076,6 +7171,101 @@
               <a:t>内容は社員間で共有して対応を決める</a:t>
             </a:r>
             <a:endParaRPr lang="en-US" sz="1200" dirty="0"/>
+          </a:p>
+        </p:txBody>
+      </p:sp>
+      <p:sp>
+        <p:nvSpPr>
+          <p:cNvPr id="22" name="rule-120"/>
+          <p:cNvSpPr/>
+          <p:nvPr/>
+        </p:nvSpPr>
+        <p:spPr>
+          <a:xfrm>
+            <a:off x="3794760" y="5394960"/>
+            <a:ext cx="7848295" cy="0"/>
+          </a:xfrm>
+          <a:prstGeom prst="line">
+            <a:avLst/>
+          </a:prstGeom>
+          <a:noFill/>
+          <a:ln w="9525">
+            <a:solidFill>
+              <a:srgbClr val="E3DCD6"/>
+            </a:solidFill>
+            <a:prstDash val="solid"/>
+          </a:ln>
+        </p:spPr>
+      </p:sp>
+      <p:sp>
+        <p:nvSpPr>
+          <p:cNvPr id="23" name="t-121"/>
+          <p:cNvSpPr txBox="1"/>
+          <p:nvPr/>
+        </p:nvSpPr>
+        <p:spPr>
+          <a:xfrm>
+            <a:off x="3794760" y="5504688"/>
+            <a:ext cx="1371600" cy="411480"/>
+          </a:xfrm>
+          <a:prstGeom prst="rect">
+            <a:avLst/>
+          </a:prstGeom>
+          <a:noFill/>
+          <a:ln/>
+        </p:spPr>
+        <p:txBody>
+          <a:bodyPr wrap="square" lIns="0" tIns="0" rIns="0" bIns="0" rtlCol="0" anchor="ctr"/>
+          <a:lstStyle/>
+          <a:p>
+            <a:pPr indent="0" marL="0">
+              <a:buNone/>
+            </a:pPr>
+            <a:r>
+              <a:rPr lang="en-US" sz="1300" b="1" dirty="0">
+                <a:solidFill>
+                  <a:schemeClr val="accent3"/>
+                </a:solidFill>
+              </a:rPr>
+              <a:t>目指す状態</a:t>
+            </a:r>
+            <a:endParaRPr lang="en-US" sz="1300" dirty="0"/>
+          </a:p>
+        </p:txBody>
+      </p:sp>
+      <p:sp>
+        <p:nvSpPr>
+          <p:cNvPr id="24" name="t-122"/>
+          <p:cNvSpPr txBox="1"/>
+          <p:nvPr/>
+        </p:nvSpPr>
+        <p:spPr>
+          <a:xfrm>
+            <a:off x="5212080" y="5504688"/>
+            <a:ext cx="6430975" cy="411480"/>
+          </a:xfrm>
+          <a:prstGeom prst="rect">
+            <a:avLst/>
+          </a:prstGeom>
+          <a:noFill/>
+          <a:ln/>
+        </p:spPr>
+        <p:txBody>
+          <a:bodyPr wrap="square" lIns="0" tIns="0" rIns="0" bIns="0" rtlCol="0" anchor="ctr"/>
+          <a:lstStyle/>
+          <a:p>
+            <a:pPr indent="0" marL="0">
+              <a:buNone/>
+            </a:pPr>
+            <a:r>
+              <a:rPr lang="en-US" sz="1400" b="1" dirty="0">
+                <a:solidFill>
+                  <a:schemeClr val="tx1"/>
+                </a:solidFill>
+              </a:rPr>
+              <a:t>学生・一般の区別なく、相談し合える職場</a:t>
+            </a:r>
+            <a:endParaRPr lang="en-US" sz="1400" dirty="0"/>
           </a:p>
         </p:txBody>
       </p:sp>
@@ -7302,7 +7492,7 @@
       </p:sp>
       <p:sp>
         <p:nvSpPr>
-          <p:cNvPr id="6" name="t-117"/>
+          <p:cNvPr id="6" name="t-123"/>
           <p:cNvSpPr txBox="1"/>
           <p:nvPr/>
         </p:nvSpPr>
@@ -7338,13 +7528,13 @@
       </p:sp>
       <p:sp>
         <p:nvSpPr>
-          <p:cNvPr id="7" name="t-118"/>
-          <p:cNvSpPr txBox="1"/>
-          <p:nvPr/>
-        </p:nvSpPr>
-        <p:spPr>
-          <a:xfrm>
-            <a:off x="3794760" y="2953512"/>
+          <p:cNvPr id="7" name="t-124"/>
+          <p:cNvSpPr txBox="1"/>
+          <p:nvPr/>
+        </p:nvSpPr>
+        <p:spPr>
+          <a:xfrm>
+            <a:off x="3794760" y="2724912"/>
             <a:ext cx="2286000" cy="274320"/>
           </a:xfrm>
           <a:prstGeom prst="rect">
@@ -7374,24 +7564,24 @@
       </p:sp>
       <p:sp>
         <p:nvSpPr>
-          <p:cNvPr id="8" name="issue-bg-119"/>
+          <p:cNvPr id="8" name="issue-bg-125"/>
           <p:cNvSpPr/>
           <p:nvPr/>
         </p:nvSpPr>
         <p:spPr>
           <a:xfrm>
             <a:off x="3794760" y="1097280"/>
-            <a:ext cx="2433218" cy="1828800"/>
+            <a:ext cx="2433218" cy="1600200"/>
           </a:xfrm>
           <a:prstGeom prst="rect">
             <a:avLst/>
           </a:prstGeom>
           <a:solidFill>
-            <a:srgbClr val="F2F2F2"/>
+            <a:srgbClr val="F6F2EF"/>
           </a:solidFill>
           <a:ln w="12700">
             <a:solidFill>
-              <a:srgbClr val="F2F2F2"/>
+              <a:srgbClr val="F6F2EF"/>
             </a:solidFill>
             <a:prstDash val="solid"/>
           </a:ln>
@@ -7399,149 +7589,16 @@
       </p:sp>
       <p:sp>
         <p:nvSpPr>
-          <p:cNvPr id="9" name="tag-bg-120"/>
+          <p:cNvPr id="9" name="tag-bg-126"/>
           <p:cNvSpPr/>
           <p:nvPr/>
         </p:nvSpPr>
         <p:spPr>
           <a:xfrm>
-            <a:off x="4023360" y="2468880"/>
-            <a:ext cx="640080" cy="274320"/>
-          </a:xfrm>
-          <a:prstGeom prst="rect">
-            <a:avLst/>
-          </a:prstGeom>
-          <a:solidFill>
-            <a:schemeClr val="accent3"/>
-          </a:solidFill>
-          <a:ln w="12700">
-            <a:solidFill>
-              <a:schemeClr val="accent3"/>
-            </a:solidFill>
-            <a:prstDash val="solid"/>
-          </a:ln>
-        </p:spPr>
-      </p:sp>
-      <p:sp>
-        <p:nvSpPr>
-          <p:cNvPr id="10" name="t-121"/>
-          <p:cNvSpPr txBox="1"/>
-          <p:nvPr/>
-        </p:nvSpPr>
-        <p:spPr>
-          <a:xfrm>
-            <a:off x="4023360" y="2468880"/>
-            <a:ext cx="640080" cy="274320"/>
-          </a:xfrm>
-          <a:prstGeom prst="rect">
-            <a:avLst/>
-          </a:prstGeom>
-          <a:noFill/>
-          <a:ln/>
-        </p:spPr>
-        <p:txBody>
-          <a:bodyPr wrap="square" lIns="0" tIns="0" rIns="0" bIns="0" rtlCol="0" anchor="ctr"/>
-          <a:lstStyle/>
-          <a:p>
-            <a:pPr algn="ctr" indent="0" marL="0">
-              <a:buNone/>
-            </a:pPr>
-            <a:r>
-              <a:rPr lang="en-US" sz="1000" b="1" dirty="0">
-                <a:solidFill>
-                  <a:schemeClr val="bg1"/>
-                </a:solidFill>
-              </a:rPr>
-              <a:t>最優先</a:t>
-            </a:r>
-            <a:endParaRPr lang="en-US" sz="1000" dirty="0"/>
-          </a:p>
-        </p:txBody>
-      </p:sp>
-      <p:sp>
-        <p:nvSpPr>
-          <p:cNvPr id="11" name="t-122"/>
-          <p:cNvSpPr txBox="1"/>
-          <p:nvPr/>
-        </p:nvSpPr>
-        <p:spPr>
-          <a:xfrm>
-            <a:off x="4023360" y="1280160"/>
-            <a:ext cx="2067458" cy="685800"/>
-          </a:xfrm>
-          <a:prstGeom prst="rect">
-            <a:avLst/>
-          </a:prstGeom>
-          <a:noFill/>
-          <a:ln/>
-        </p:spPr>
-        <p:txBody>
-          <a:bodyPr wrap="square" lIns="0" tIns="0" rIns="0" bIns="0" rtlCol="0" anchor="t"/>
-          <a:lstStyle/>
-          <a:p>
-            <a:pPr indent="0" marL="0">
-              <a:buNone/>
-            </a:pPr>
-            <a:r>
-              <a:rPr lang="en-US" sz="1500" b="1" dirty="0">
-                <a:solidFill>
-                  <a:schemeClr val="tx1"/>
-                </a:solidFill>
-              </a:rPr>
-              <a:t>ゆで麺器</a:t>
-            </a:r>
-            <a:endParaRPr lang="en-US" sz="1500" dirty="0"/>
-          </a:p>
-        </p:txBody>
-      </p:sp>
-      <p:sp>
-        <p:nvSpPr>
-          <p:cNvPr id="12" name="t-123"/>
-          <p:cNvSpPr txBox="1"/>
-          <p:nvPr/>
-        </p:nvSpPr>
-        <p:spPr>
-          <a:xfrm>
-            <a:off x="4023360" y="1737360"/>
-            <a:ext cx="2021738" cy="685800"/>
-          </a:xfrm>
-          <a:prstGeom prst="rect">
-            <a:avLst/>
-          </a:prstGeom>
-          <a:noFill/>
-          <a:ln/>
-        </p:spPr>
-        <p:txBody>
-          <a:bodyPr wrap="square" lIns="0" tIns="0" rIns="0" bIns="0" rtlCol="0" anchor="t"/>
-          <a:lstStyle/>
-          <a:p>
-            <a:pPr indent="0" marL="0">
-              <a:buNone/>
-            </a:pPr>
-            <a:r>
-              <a:rPr lang="en-US" sz="1200" dirty="0">
-                <a:solidFill>
-                  <a:schemeClr val="tx2"/>
-                </a:solidFill>
-              </a:rPr>
-              <a:t>急に火力が落ちて沸き上がらないことがある。コラボで冷凍麺が増えると提供できない</a:t>
-            </a:r>
-            <a:endParaRPr lang="en-US" sz="1200" dirty="0"/>
-          </a:p>
-        </p:txBody>
-      </p:sp>
-      <p:sp>
-        <p:nvSpPr>
-          <p:cNvPr id="13" name="arrow-124"/>
-          <p:cNvSpPr/>
-          <p:nvPr/>
-        </p:nvSpPr>
-        <p:spPr>
-          <a:xfrm rot="10800000">
-            <a:off x="4855921" y="3017520"/>
-            <a:ext cx="310896" cy="201168"/>
-          </a:xfrm>
-          <a:prstGeom prst="triangle">
+            <a:off x="5569610" y="1298448"/>
+            <a:ext cx="548640" cy="256032"/>
+          </a:xfrm>
+          <a:prstGeom prst="rect">
             <a:avLst/>
           </a:prstGeom>
           <a:solidFill>
@@ -7557,14 +7614,147 @@
       </p:sp>
       <p:sp>
         <p:nvSpPr>
-          <p:cNvPr id="14" name="act-bg-125"/>
+          <p:cNvPr id="10" name="t-127"/>
+          <p:cNvSpPr txBox="1"/>
+          <p:nvPr/>
+        </p:nvSpPr>
+        <p:spPr>
+          <a:xfrm>
+            <a:off x="5569610" y="1298448"/>
+            <a:ext cx="548640" cy="256032"/>
+          </a:xfrm>
+          <a:prstGeom prst="rect">
+            <a:avLst/>
+          </a:prstGeom>
+          <a:noFill/>
+          <a:ln/>
+        </p:spPr>
+        <p:txBody>
+          <a:bodyPr wrap="square" lIns="0" tIns="0" rIns="0" bIns="0" rtlCol="0" anchor="ctr"/>
+          <a:lstStyle/>
+          <a:p>
+            <a:pPr algn="ctr" indent="0" marL="0">
+              <a:buNone/>
+            </a:pPr>
+            <a:r>
+              <a:rPr lang="en-US" sz="900" b="1" dirty="0">
+                <a:solidFill>
+                  <a:schemeClr val="bg1"/>
+                </a:solidFill>
+              </a:rPr>
+              <a:t>最優先</a:t>
+            </a:r>
+            <a:endParaRPr lang="en-US" sz="900" dirty="0"/>
+          </a:p>
+        </p:txBody>
+      </p:sp>
+      <p:sp>
+        <p:nvSpPr>
+          <p:cNvPr id="11" name="t-128"/>
+          <p:cNvSpPr txBox="1"/>
+          <p:nvPr/>
+        </p:nvSpPr>
+        <p:spPr>
+          <a:xfrm>
+            <a:off x="4023360" y="1280160"/>
+            <a:ext cx="1518818" cy="411480"/>
+          </a:xfrm>
+          <a:prstGeom prst="rect">
+            <a:avLst/>
+          </a:prstGeom>
+          <a:noFill/>
+          <a:ln/>
+        </p:spPr>
+        <p:txBody>
+          <a:bodyPr wrap="square" lIns="0" tIns="0" rIns="0" bIns="0" rtlCol="0" anchor="t"/>
+          <a:lstStyle/>
+          <a:p>
+            <a:pPr indent="0" marL="0">
+              <a:buNone/>
+            </a:pPr>
+            <a:r>
+              <a:rPr lang="en-US" sz="1500" b="1" dirty="0">
+                <a:solidFill>
+                  <a:schemeClr val="tx1"/>
+                </a:solidFill>
+              </a:rPr>
+              <a:t>ゆで麺器</a:t>
+            </a:r>
+            <a:endParaRPr lang="en-US" sz="1500" dirty="0"/>
+          </a:p>
+        </p:txBody>
+      </p:sp>
+      <p:sp>
+        <p:nvSpPr>
+          <p:cNvPr id="12" name="t-129"/>
+          <p:cNvSpPr txBox="1"/>
+          <p:nvPr/>
+        </p:nvSpPr>
+        <p:spPr>
+          <a:xfrm>
+            <a:off x="4023360" y="1737360"/>
+            <a:ext cx="2021738" cy="457200"/>
+          </a:xfrm>
+          <a:prstGeom prst="rect">
+            <a:avLst/>
+          </a:prstGeom>
+          <a:noFill/>
+          <a:ln/>
+        </p:spPr>
+        <p:txBody>
+          <a:bodyPr wrap="square" lIns="0" tIns="0" rIns="0" bIns="0" rtlCol="0" anchor="t"/>
+          <a:lstStyle/>
+          <a:p>
+            <a:pPr indent="0" marL="0">
+              <a:buNone/>
+            </a:pPr>
+            <a:r>
+              <a:rPr lang="en-US" sz="1200" dirty="0">
+                <a:solidFill>
+                  <a:schemeClr val="tx2"/>
+                </a:solidFill>
+              </a:rPr>
+              <a:t>急に火力が落ちて沸き上がらないことがある。冷凍麺が増えると提供不可</a:t>
+            </a:r>
+            <a:endParaRPr lang="en-US" sz="1200" dirty="0"/>
+          </a:p>
+        </p:txBody>
+      </p:sp>
+      <p:sp>
+        <p:nvSpPr>
+          <p:cNvPr id="13" name="arrow-130"/>
           <p:cNvSpPr/>
           <p:nvPr/>
         </p:nvSpPr>
         <p:spPr>
-          <a:xfrm>
-            <a:off x="3794760" y="3337560"/>
-            <a:ext cx="2433218" cy="2514600"/>
+          <a:xfrm rot="10800000">
+            <a:off x="4855921" y="2788920"/>
+            <a:ext cx="310896" cy="201168"/>
+          </a:xfrm>
+          <a:prstGeom prst="triangle">
+            <a:avLst/>
+          </a:prstGeom>
+          <a:solidFill>
+            <a:schemeClr val="accent1"/>
+          </a:solidFill>
+          <a:ln w="12700">
+            <a:solidFill>
+              <a:schemeClr val="accent1"/>
+            </a:solidFill>
+            <a:prstDash val="solid"/>
+          </a:ln>
+        </p:spPr>
+      </p:sp>
+      <p:sp>
+        <p:nvSpPr>
+          <p:cNvPr id="14" name="act-bg-131"/>
+          <p:cNvSpPr/>
+          <p:nvPr/>
+        </p:nvSpPr>
+        <p:spPr>
+          <a:xfrm>
+            <a:off x="3794760" y="3108960"/>
+            <a:ext cx="2433218" cy="2011680"/>
           </a:xfrm>
           <a:prstGeom prst="rect">
             <a:avLst/>
@@ -7582,13 +7772,13 @@
       </p:sp>
       <p:sp>
         <p:nvSpPr>
-          <p:cNvPr id="15" name="t-126"/>
-          <p:cNvSpPr txBox="1"/>
-          <p:nvPr/>
-        </p:nvSpPr>
-        <p:spPr>
-          <a:xfrm>
-            <a:off x="4023360" y="3520440"/>
+          <p:cNvPr id="15" name="t-132"/>
+          <p:cNvSpPr txBox="1"/>
+          <p:nvPr/>
+        </p:nvSpPr>
+        <p:spPr>
+          <a:xfrm>
+            <a:off x="4023360" y="3291840"/>
             <a:ext cx="2067458" cy="685800"/>
           </a:xfrm>
           <a:prstGeom prst="rect">
@@ -7618,14 +7808,14 @@
       </p:sp>
       <p:sp>
         <p:nvSpPr>
-          <p:cNvPr id="16" name="t-127"/>
-          <p:cNvSpPr txBox="1"/>
-          <p:nvPr/>
-        </p:nvSpPr>
-        <p:spPr>
-          <a:xfrm>
-            <a:off x="4023360" y="4023360"/>
-            <a:ext cx="2021738" cy="1691640"/>
+          <p:cNvPr id="16" name="t-133"/>
+          <p:cNvSpPr txBox="1"/>
+          <p:nvPr/>
+        </p:nvSpPr>
+        <p:spPr>
+          <a:xfrm>
+            <a:off x="4023360" y="3794760"/>
+            <a:ext cx="2021738" cy="1188720"/>
           </a:xfrm>
           <a:prstGeom prst="rect">
             <a:avLst/>
@@ -7676,24 +7866,24 @@
       </p:sp>
       <p:sp>
         <p:nvSpPr>
-          <p:cNvPr id="17" name="issue-bg-128"/>
+          <p:cNvPr id="17" name="issue-bg-134"/>
           <p:cNvSpPr/>
           <p:nvPr/>
         </p:nvSpPr>
         <p:spPr>
           <a:xfrm>
             <a:off x="6502298" y="1097280"/>
-            <a:ext cx="2433218" cy="1828800"/>
+            <a:ext cx="2433218" cy="1600200"/>
           </a:xfrm>
           <a:prstGeom prst="rect">
             <a:avLst/>
           </a:prstGeom>
           <a:solidFill>
-            <a:srgbClr val="F2F2F2"/>
+            <a:srgbClr val="F6F2EF"/>
           </a:solidFill>
           <a:ln w="12700">
             <a:solidFill>
-              <a:srgbClr val="F2F2F2"/>
+              <a:srgbClr val="F6F2EF"/>
             </a:solidFill>
             <a:prstDash val="solid"/>
           </a:ln>
@@ -7701,14 +7891,14 @@
       </p:sp>
       <p:sp>
         <p:nvSpPr>
-          <p:cNvPr id="18" name="t-129"/>
+          <p:cNvPr id="18" name="t-135"/>
           <p:cNvSpPr txBox="1"/>
           <p:nvPr/>
         </p:nvSpPr>
         <p:spPr>
           <a:xfrm>
             <a:off x="6730898" y="1280160"/>
-            <a:ext cx="2067458" cy="685800"/>
+            <a:ext cx="2067458" cy="411480"/>
           </a:xfrm>
           <a:prstGeom prst="rect">
             <a:avLst/>
@@ -7737,14 +7927,14 @@
       </p:sp>
       <p:sp>
         <p:nvSpPr>
-          <p:cNvPr id="19" name="t-130"/>
+          <p:cNvPr id="19" name="t-136"/>
           <p:cNvSpPr txBox="1"/>
           <p:nvPr/>
         </p:nvSpPr>
         <p:spPr>
           <a:xfrm>
             <a:off x="6730898" y="1737360"/>
-            <a:ext cx="2021738" cy="685800"/>
+            <a:ext cx="2021738" cy="457200"/>
           </a:xfrm>
           <a:prstGeom prst="rect">
             <a:avLst/>
@@ -7773,13 +7963,13 @@
       </p:sp>
       <p:sp>
         <p:nvSpPr>
-          <p:cNvPr id="20" name="arrow-131"/>
+          <p:cNvPr id="20" name="arrow-137"/>
           <p:cNvSpPr/>
           <p:nvPr/>
         </p:nvSpPr>
         <p:spPr>
           <a:xfrm rot="10800000">
-            <a:off x="7563460" y="3017520"/>
+            <a:off x="7563460" y="2788920"/>
             <a:ext cx="310896" cy="201168"/>
           </a:xfrm>
           <a:prstGeom prst="triangle">
@@ -7798,14 +7988,14 @@
       </p:sp>
       <p:sp>
         <p:nvSpPr>
-          <p:cNvPr id="21" name="act-bg-132"/>
+          <p:cNvPr id="21" name="act-bg-138"/>
           <p:cNvSpPr/>
           <p:nvPr/>
         </p:nvSpPr>
         <p:spPr>
           <a:xfrm>
-            <a:off x="6502298" y="3337560"/>
-            <a:ext cx="2433218" cy="2514600"/>
+            <a:off x="6502298" y="3108960"/>
+            <a:ext cx="2433218" cy="2011680"/>
           </a:xfrm>
           <a:prstGeom prst="rect">
             <a:avLst/>
@@ -7823,13 +8013,13 @@
       </p:sp>
       <p:sp>
         <p:nvSpPr>
-          <p:cNvPr id="22" name="t-133"/>
-          <p:cNvSpPr txBox="1"/>
-          <p:nvPr/>
-        </p:nvSpPr>
-        <p:spPr>
-          <a:xfrm>
-            <a:off x="6730898" y="3520440"/>
+          <p:cNvPr id="22" name="t-139"/>
+          <p:cNvSpPr txBox="1"/>
+          <p:nvPr/>
+        </p:nvSpPr>
+        <p:spPr>
+          <a:xfrm>
+            <a:off x="6730898" y="3291840"/>
             <a:ext cx="2067458" cy="685800"/>
           </a:xfrm>
           <a:prstGeom prst="rect">
@@ -7859,14 +8049,14 @@
       </p:sp>
       <p:sp>
         <p:nvSpPr>
-          <p:cNvPr id="23" name="t-134"/>
-          <p:cNvSpPr txBox="1"/>
-          <p:nvPr/>
-        </p:nvSpPr>
-        <p:spPr>
-          <a:xfrm>
-            <a:off x="6730898" y="4023360"/>
-            <a:ext cx="2021738" cy="1691640"/>
+          <p:cNvPr id="23" name="t-140"/>
+          <p:cNvSpPr txBox="1"/>
+          <p:nvPr/>
+        </p:nvSpPr>
+        <p:spPr>
+          <a:xfrm>
+            <a:off x="6730898" y="3794760"/>
+            <a:ext cx="2021738" cy="1188720"/>
           </a:xfrm>
           <a:prstGeom prst="rect">
             <a:avLst/>
@@ -7917,24 +8107,24 @@
       </p:sp>
       <p:sp>
         <p:nvSpPr>
-          <p:cNvPr id="24" name="issue-bg-135"/>
+          <p:cNvPr id="24" name="issue-bg-141"/>
           <p:cNvSpPr/>
           <p:nvPr/>
         </p:nvSpPr>
         <p:spPr>
           <a:xfrm>
             <a:off x="9209837" y="1097280"/>
-            <a:ext cx="2433218" cy="1828800"/>
+            <a:ext cx="2433218" cy="1600200"/>
           </a:xfrm>
           <a:prstGeom prst="rect">
             <a:avLst/>
           </a:prstGeom>
           <a:solidFill>
-            <a:srgbClr val="F2F2F2"/>
+            <a:srgbClr val="F6F2EF"/>
           </a:solidFill>
           <a:ln w="12700">
             <a:solidFill>
-              <a:srgbClr val="F2F2F2"/>
+              <a:srgbClr val="F6F2EF"/>
             </a:solidFill>
             <a:prstDash val="solid"/>
           </a:ln>
@@ -7942,14 +8132,14 @@
       </p:sp>
       <p:sp>
         <p:nvSpPr>
-          <p:cNvPr id="25" name="t-136"/>
+          <p:cNvPr id="25" name="t-142"/>
           <p:cNvSpPr txBox="1"/>
           <p:nvPr/>
         </p:nvSpPr>
         <p:spPr>
           <a:xfrm>
             <a:off x="9438437" y="1280160"/>
-            <a:ext cx="2067458" cy="685800"/>
+            <a:ext cx="2067458" cy="411480"/>
           </a:xfrm>
           <a:prstGeom prst="rect">
             <a:avLst/>
@@ -7978,14 +8168,14 @@
       </p:sp>
       <p:sp>
         <p:nvSpPr>
-          <p:cNvPr id="26" name="t-137"/>
+          <p:cNvPr id="26" name="t-143"/>
           <p:cNvSpPr txBox="1"/>
           <p:nvPr/>
         </p:nvSpPr>
         <p:spPr>
           <a:xfrm>
             <a:off x="9438437" y="1737360"/>
-            <a:ext cx="2021738" cy="685800"/>
+            <a:ext cx="2021738" cy="457200"/>
           </a:xfrm>
           <a:prstGeom prst="rect">
             <a:avLst/>
@@ -8014,13 +8204,13 @@
       </p:sp>
       <p:sp>
         <p:nvSpPr>
-          <p:cNvPr id="27" name="arrow-138"/>
+          <p:cNvPr id="27" name="arrow-144"/>
           <p:cNvSpPr/>
           <p:nvPr/>
         </p:nvSpPr>
         <p:spPr>
           <a:xfrm rot="10800000">
-            <a:off x="10270998" y="3017520"/>
+            <a:off x="10270998" y="2788920"/>
             <a:ext cx="310896" cy="201168"/>
           </a:xfrm>
           <a:prstGeom prst="triangle">
@@ -8039,14 +8229,14 @@
       </p:sp>
       <p:sp>
         <p:nvSpPr>
-          <p:cNvPr id="28" name="act-bg-139"/>
+          <p:cNvPr id="28" name="act-bg-145"/>
           <p:cNvSpPr/>
           <p:nvPr/>
         </p:nvSpPr>
         <p:spPr>
           <a:xfrm>
-            <a:off x="9209837" y="3337560"/>
-            <a:ext cx="2433218" cy="2514600"/>
+            <a:off x="9209837" y="3108960"/>
+            <a:ext cx="2433218" cy="2011680"/>
           </a:xfrm>
           <a:prstGeom prst="rect">
             <a:avLst/>
@@ -8064,13 +8254,13 @@
       </p:sp>
       <p:sp>
         <p:nvSpPr>
-          <p:cNvPr id="29" name="t-140"/>
-          <p:cNvSpPr txBox="1"/>
-          <p:nvPr/>
-        </p:nvSpPr>
-        <p:spPr>
-          <a:xfrm>
-            <a:off x="9438437" y="3520440"/>
+          <p:cNvPr id="29" name="t-146"/>
+          <p:cNvSpPr txBox="1"/>
+          <p:nvPr/>
+        </p:nvSpPr>
+        <p:spPr>
+          <a:xfrm>
+            <a:off x="9438437" y="3291840"/>
             <a:ext cx="2067458" cy="685800"/>
           </a:xfrm>
           <a:prstGeom prst="rect">
@@ -8100,14 +8290,14 @@
       </p:sp>
       <p:sp>
         <p:nvSpPr>
-          <p:cNvPr id="30" name="t-141"/>
-          <p:cNvSpPr txBox="1"/>
-          <p:nvPr/>
-        </p:nvSpPr>
-        <p:spPr>
-          <a:xfrm>
-            <a:off x="9438437" y="4023360"/>
-            <a:ext cx="2021738" cy="1691640"/>
+          <p:cNvPr id="30" name="t-147"/>
+          <p:cNvSpPr txBox="1"/>
+          <p:nvPr/>
+        </p:nvSpPr>
+        <p:spPr>
+          <a:xfrm>
+            <a:off x="9438437" y="3794760"/>
+            <a:ext cx="2021738" cy="1188720"/>
           </a:xfrm>
           <a:prstGeom prst="rect">
             <a:avLst/>
@@ -8153,6 +8343,101 @@
               <a:t>コンセントと合わせて依頼</a:t>
             </a:r>
             <a:endParaRPr lang="en-US" sz="1200" dirty="0"/>
+          </a:p>
+        </p:txBody>
+      </p:sp>
+      <p:sp>
+        <p:nvSpPr>
+          <p:cNvPr id="31" name="rule-148"/>
+          <p:cNvSpPr/>
+          <p:nvPr/>
+        </p:nvSpPr>
+        <p:spPr>
+          <a:xfrm>
+            <a:off x="3794760" y="5394960"/>
+            <a:ext cx="7848295" cy="0"/>
+          </a:xfrm>
+          <a:prstGeom prst="line">
+            <a:avLst/>
+          </a:prstGeom>
+          <a:noFill/>
+          <a:ln w="9525">
+            <a:solidFill>
+              <a:srgbClr val="E3DCD6"/>
+            </a:solidFill>
+            <a:prstDash val="solid"/>
+          </a:ln>
+        </p:spPr>
+      </p:sp>
+      <p:sp>
+        <p:nvSpPr>
+          <p:cNvPr id="32" name="t-149"/>
+          <p:cNvSpPr txBox="1"/>
+          <p:nvPr/>
+        </p:nvSpPr>
+        <p:spPr>
+          <a:xfrm>
+            <a:off x="3794760" y="5504688"/>
+            <a:ext cx="1371600" cy="411480"/>
+          </a:xfrm>
+          <a:prstGeom prst="rect">
+            <a:avLst/>
+          </a:prstGeom>
+          <a:noFill/>
+          <a:ln/>
+        </p:spPr>
+        <p:txBody>
+          <a:bodyPr wrap="square" lIns="0" tIns="0" rIns="0" bIns="0" rtlCol="0" anchor="ctr"/>
+          <a:lstStyle/>
+          <a:p>
+            <a:pPr indent="0" marL="0">
+              <a:buNone/>
+            </a:pPr>
+            <a:r>
+              <a:rPr lang="en-US" sz="1300" b="1" dirty="0">
+                <a:solidFill>
+                  <a:schemeClr val="accent3"/>
+                </a:solidFill>
+              </a:rPr>
+              <a:t>目指す状態</a:t>
+            </a:r>
+            <a:endParaRPr lang="en-US" sz="1300" dirty="0"/>
+          </a:p>
+        </p:txBody>
+      </p:sp>
+      <p:sp>
+        <p:nvSpPr>
+          <p:cNvPr id="33" name="t-150"/>
+          <p:cNvSpPr txBox="1"/>
+          <p:nvPr/>
+        </p:nvSpPr>
+        <p:spPr>
+          <a:xfrm>
+            <a:off x="5212080" y="5504688"/>
+            <a:ext cx="6430975" cy="411480"/>
+          </a:xfrm>
+          <a:prstGeom prst="rect">
+            <a:avLst/>
+          </a:prstGeom>
+          <a:noFill/>
+          <a:ln/>
+        </p:spPr>
+        <p:txBody>
+          <a:bodyPr wrap="square" lIns="0" tIns="0" rIns="0" bIns="0" rtlCol="0" anchor="ctr"/>
+          <a:lstStyle/>
+          <a:p>
+            <a:pPr indent="0" marL="0">
+              <a:buNone/>
+            </a:pPr>
+            <a:r>
+              <a:rPr lang="en-US" sz="1400" b="1" dirty="0">
+                <a:solidFill>
+                  <a:schemeClr val="tx1"/>
+                </a:solidFill>
+              </a:rPr>
+              <a:t>コラボの繁忙期でも提供が止まらない厨房</a:t>
+            </a:r>
+            <a:endParaRPr lang="en-US" sz="1400" dirty="0"/>
           </a:p>
         </p:txBody>
       </p:sp>
@@ -8396,7 +8681,7 @@
       </p:sp>
       <p:sp>
         <p:nvSpPr>
-          <p:cNvPr id="6" name="rule-142"/>
+          <p:cNvPr id="6" name="rule-151"/>
           <p:cNvSpPr/>
           <p:nvPr/>
         </p:nvSpPr>
@@ -8411,7 +8696,7 @@
           <a:noFill/>
           <a:ln w="25400">
             <a:solidFill>
-              <a:srgbClr val="2F5D50"/>
+              <a:srgbClr val="B5532F"/>
             </a:solidFill>
             <a:prstDash val="solid"/>
           </a:ln>
@@ -8419,7 +8704,7 @@
       </p:sp>
       <p:sp>
         <p:nvSpPr>
-          <p:cNvPr id="7" name="dot-143"/>
+          <p:cNvPr id="7" name="dot-152"/>
           <p:cNvSpPr/>
           <p:nvPr/>
         </p:nvSpPr>
@@ -8444,7 +8729,7 @@
       </p:sp>
       <p:sp>
         <p:nvSpPr>
-          <p:cNvPr id="8" name="t-144"/>
+          <p:cNvPr id="8" name="t-153"/>
           <p:cNvSpPr txBox="1"/>
           <p:nvPr/>
         </p:nvSpPr>
@@ -8480,7 +8765,7 @@
       </p:sp>
       <p:sp>
         <p:nvSpPr>
-          <p:cNvPr id="9" name="task-bg-145"/>
+          <p:cNvPr id="9" name="task-bg-154"/>
           <p:cNvSpPr/>
           <p:nvPr/>
         </p:nvSpPr>
@@ -8493,11 +8778,11 @@
             <a:avLst/>
           </a:prstGeom>
           <a:solidFill>
-            <a:srgbClr val="F2F2F2"/>
+            <a:srgbClr val="F6F2EF"/>
           </a:solidFill>
           <a:ln w="12700">
             <a:solidFill>
-              <a:srgbClr val="F2F2F2"/>
+              <a:srgbClr val="F6F2EF"/>
             </a:solidFill>
             <a:prstDash val="solid"/>
           </a:ln>
@@ -8505,7 +8790,7 @@
       </p:sp>
       <p:sp>
         <p:nvSpPr>
-          <p:cNvPr id="10" name="t-146"/>
+          <p:cNvPr id="10" name="t-155"/>
           <p:cNvSpPr txBox="1"/>
           <p:nvPr/>
         </p:nvSpPr>
@@ -8541,7 +8826,7 @@
       </p:sp>
       <p:sp>
         <p:nvSpPr>
-          <p:cNvPr id="11" name="t-147"/>
+          <p:cNvPr id="11" name="t-156"/>
           <p:cNvSpPr txBox="1"/>
           <p:nvPr/>
         </p:nvSpPr>
@@ -8577,7 +8862,7 @@
       </p:sp>
       <p:sp>
         <p:nvSpPr>
-          <p:cNvPr id="12" name="t-148"/>
+          <p:cNvPr id="12" name="t-157"/>
           <p:cNvSpPr txBox="1"/>
           <p:nvPr/>
         </p:nvSpPr>
@@ -8613,7 +8898,7 @@
       </p:sp>
       <p:sp>
         <p:nvSpPr>
-          <p:cNvPr id="13" name="rule-149"/>
+          <p:cNvPr id="13" name="rule-158"/>
           <p:cNvSpPr/>
           <p:nvPr/>
         </p:nvSpPr>
@@ -8628,7 +8913,7 @@
           <a:noFill/>
           <a:ln w="9525">
             <a:solidFill>
-              <a:srgbClr val="8C8C8C"/>
+              <a:srgbClr val="9A918B"/>
             </a:solidFill>
             <a:prstDash val="solid"/>
           </a:ln>
@@ -8636,7 +8921,7 @@
       </p:sp>
       <p:sp>
         <p:nvSpPr>
-          <p:cNvPr id="14" name="task-bg-150"/>
+          <p:cNvPr id="14" name="task-bg-159"/>
           <p:cNvSpPr/>
           <p:nvPr/>
         </p:nvSpPr>
@@ -8649,11 +8934,11 @@
             <a:avLst/>
           </a:prstGeom>
           <a:solidFill>
-            <a:srgbClr val="F2F2F2"/>
+            <a:srgbClr val="F6F2EF"/>
           </a:solidFill>
           <a:ln w="12700">
             <a:solidFill>
-              <a:srgbClr val="F2F2F2"/>
+              <a:srgbClr val="F6F2EF"/>
             </a:solidFill>
             <a:prstDash val="solid"/>
           </a:ln>
@@ -8661,7 +8946,7 @@
       </p:sp>
       <p:sp>
         <p:nvSpPr>
-          <p:cNvPr id="15" name="t-151"/>
+          <p:cNvPr id="15" name="t-160"/>
           <p:cNvSpPr txBox="1"/>
           <p:nvPr/>
         </p:nvSpPr>
@@ -8697,7 +8982,7 @@
       </p:sp>
       <p:sp>
         <p:nvSpPr>
-          <p:cNvPr id="16" name="t-152"/>
+          <p:cNvPr id="16" name="t-161"/>
           <p:cNvSpPr txBox="1"/>
           <p:nvPr/>
         </p:nvSpPr>
@@ -8733,7 +9018,7 @@
       </p:sp>
       <p:sp>
         <p:nvSpPr>
-          <p:cNvPr id="17" name="t-153"/>
+          <p:cNvPr id="17" name="t-162"/>
           <p:cNvSpPr txBox="1"/>
           <p:nvPr/>
         </p:nvSpPr>
@@ -8769,7 +9054,7 @@
       </p:sp>
       <p:sp>
         <p:nvSpPr>
-          <p:cNvPr id="18" name="rule-154"/>
+          <p:cNvPr id="18" name="rule-163"/>
           <p:cNvSpPr/>
           <p:nvPr/>
         </p:nvSpPr>
@@ -8784,7 +9069,7 @@
           <a:noFill/>
           <a:ln w="9525">
             <a:solidFill>
-              <a:srgbClr val="8C8C8C"/>
+              <a:srgbClr val="9A918B"/>
             </a:solidFill>
             <a:prstDash val="solid"/>
           </a:ln>
@@ -8792,7 +9077,7 @@
       </p:sp>
       <p:sp>
         <p:nvSpPr>
-          <p:cNvPr id="19" name="dot-155"/>
+          <p:cNvPr id="19" name="dot-164"/>
           <p:cNvSpPr/>
           <p:nvPr/>
         </p:nvSpPr>
@@ -8817,7 +9102,7 @@
       </p:sp>
       <p:sp>
         <p:nvSpPr>
-          <p:cNvPr id="20" name="t-156"/>
+          <p:cNvPr id="20" name="t-165"/>
           <p:cNvSpPr txBox="1"/>
           <p:nvPr/>
         </p:nvSpPr>
@@ -8853,7 +9138,7 @@
       </p:sp>
       <p:sp>
         <p:nvSpPr>
-          <p:cNvPr id="21" name="task-bg-157"/>
+          <p:cNvPr id="21" name="task-bg-166"/>
           <p:cNvSpPr/>
           <p:nvPr/>
         </p:nvSpPr>
@@ -8866,11 +9151,11 @@
             <a:avLst/>
           </a:prstGeom>
           <a:solidFill>
-            <a:srgbClr val="F2F2F2"/>
+            <a:srgbClr val="F6F2EF"/>
           </a:solidFill>
           <a:ln w="12700">
             <a:solidFill>
-              <a:srgbClr val="F2F2F2"/>
+              <a:srgbClr val="F6F2EF"/>
             </a:solidFill>
             <a:prstDash val="solid"/>
           </a:ln>
@@ -8878,7 +9163,7 @@
       </p:sp>
       <p:sp>
         <p:nvSpPr>
-          <p:cNvPr id="22" name="t-158"/>
+          <p:cNvPr id="22" name="t-167"/>
           <p:cNvSpPr txBox="1"/>
           <p:nvPr/>
         </p:nvSpPr>
@@ -8914,7 +9199,7 @@
       </p:sp>
       <p:sp>
         <p:nvSpPr>
-          <p:cNvPr id="23" name="t-159"/>
+          <p:cNvPr id="23" name="t-168"/>
           <p:cNvSpPr txBox="1"/>
           <p:nvPr/>
         </p:nvSpPr>
@@ -8950,7 +9235,7 @@
       </p:sp>
       <p:sp>
         <p:nvSpPr>
-          <p:cNvPr id="24" name="t-160"/>
+          <p:cNvPr id="24" name="t-169"/>
           <p:cNvSpPr txBox="1"/>
           <p:nvPr/>
         </p:nvSpPr>
@@ -8986,7 +9271,7 @@
       </p:sp>
       <p:sp>
         <p:nvSpPr>
-          <p:cNvPr id="25" name="rule-161"/>
+          <p:cNvPr id="25" name="rule-170"/>
           <p:cNvSpPr/>
           <p:nvPr/>
         </p:nvSpPr>
@@ -9001,7 +9286,7 @@
           <a:noFill/>
           <a:ln w="9525">
             <a:solidFill>
-              <a:srgbClr val="8C8C8C"/>
+              <a:srgbClr val="9A918B"/>
             </a:solidFill>
             <a:prstDash val="solid"/>
           </a:ln>
@@ -9009,7 +9294,7 @@
       </p:sp>
       <p:sp>
         <p:nvSpPr>
-          <p:cNvPr id="26" name="task-bg-162"/>
+          <p:cNvPr id="26" name="task-bg-171"/>
           <p:cNvSpPr/>
           <p:nvPr/>
         </p:nvSpPr>
@@ -9022,11 +9307,11 @@
             <a:avLst/>
           </a:prstGeom>
           <a:solidFill>
-            <a:srgbClr val="F2F2F2"/>
+            <a:srgbClr val="F6F2EF"/>
           </a:solidFill>
           <a:ln w="12700">
             <a:solidFill>
-              <a:srgbClr val="F2F2F2"/>
+              <a:srgbClr val="F6F2EF"/>
             </a:solidFill>
             <a:prstDash val="solid"/>
           </a:ln>
@@ -9034,7 +9319,7 @@
       </p:sp>
       <p:sp>
         <p:nvSpPr>
-          <p:cNvPr id="27" name="t-163"/>
+          <p:cNvPr id="27" name="t-172"/>
           <p:cNvSpPr txBox="1"/>
           <p:nvPr/>
         </p:nvSpPr>
@@ -9070,7 +9355,7 @@
       </p:sp>
       <p:sp>
         <p:nvSpPr>
-          <p:cNvPr id="28" name="t-164"/>
+          <p:cNvPr id="28" name="t-173"/>
           <p:cNvSpPr txBox="1"/>
           <p:nvPr/>
         </p:nvSpPr>
@@ -9106,7 +9391,7 @@
       </p:sp>
       <p:sp>
         <p:nvSpPr>
-          <p:cNvPr id="29" name="t-165"/>
+          <p:cNvPr id="29" name="t-174"/>
           <p:cNvSpPr txBox="1"/>
           <p:nvPr/>
         </p:nvSpPr>
@@ -9142,7 +9427,7 @@
       </p:sp>
       <p:sp>
         <p:nvSpPr>
-          <p:cNvPr id="30" name="rule-166"/>
+          <p:cNvPr id="30" name="rule-175"/>
           <p:cNvSpPr/>
           <p:nvPr/>
         </p:nvSpPr>
@@ -9157,7 +9442,7 @@
           <a:noFill/>
           <a:ln w="9525">
             <a:solidFill>
-              <a:srgbClr val="8C8C8C"/>
+              <a:srgbClr val="9A918B"/>
             </a:solidFill>
             <a:prstDash val="solid"/>
           </a:ln>
@@ -9165,7 +9450,7 @@
       </p:sp>
       <p:sp>
         <p:nvSpPr>
-          <p:cNvPr id="31" name="dot-167"/>
+          <p:cNvPr id="31" name="dot-176"/>
           <p:cNvSpPr/>
           <p:nvPr/>
         </p:nvSpPr>
@@ -9190,7 +9475,7 @@
       </p:sp>
       <p:sp>
         <p:nvSpPr>
-          <p:cNvPr id="32" name="t-168"/>
+          <p:cNvPr id="32" name="t-177"/>
           <p:cNvSpPr txBox="1"/>
           <p:nvPr/>
         </p:nvSpPr>
@@ -9226,7 +9511,7 @@
       </p:sp>
       <p:sp>
         <p:nvSpPr>
-          <p:cNvPr id="33" name="task-bg-169"/>
+          <p:cNvPr id="33" name="task-bg-178"/>
           <p:cNvSpPr/>
           <p:nvPr/>
         </p:nvSpPr>
@@ -9239,11 +9524,11 @@
             <a:avLst/>
           </a:prstGeom>
           <a:solidFill>
-            <a:srgbClr val="F2F2F2"/>
+            <a:srgbClr val="F6F2EF"/>
           </a:solidFill>
           <a:ln w="12700">
             <a:solidFill>
-              <a:srgbClr val="F2F2F2"/>
+              <a:srgbClr val="F6F2EF"/>
             </a:solidFill>
             <a:prstDash val="solid"/>
           </a:ln>
@@ -9251,7 +9536,7 @@
       </p:sp>
       <p:sp>
         <p:nvSpPr>
-          <p:cNvPr id="34" name="t-170"/>
+          <p:cNvPr id="34" name="t-179"/>
           <p:cNvSpPr txBox="1"/>
           <p:nvPr/>
         </p:nvSpPr>
@@ -9287,7 +9572,7 @@
       </p:sp>
       <p:sp>
         <p:nvSpPr>
-          <p:cNvPr id="35" name="t-171"/>
+          <p:cNvPr id="35" name="t-180"/>
           <p:cNvSpPr txBox="1"/>
           <p:nvPr/>
         </p:nvSpPr>
@@ -9323,7 +9608,7 @@
       </p:sp>
       <p:sp>
         <p:nvSpPr>
-          <p:cNvPr id="36" name="t-172"/>
+          <p:cNvPr id="36" name="t-181"/>
           <p:cNvSpPr txBox="1"/>
           <p:nvPr/>
         </p:nvSpPr>
@@ -9359,7 +9644,7 @@
       </p:sp>
       <p:sp>
         <p:nvSpPr>
-          <p:cNvPr id="37" name="rule-173"/>
+          <p:cNvPr id="37" name="rule-182"/>
           <p:cNvSpPr/>
           <p:nvPr/>
         </p:nvSpPr>
@@ -9374,7 +9659,7 @@
           <a:noFill/>
           <a:ln w="9525">
             <a:solidFill>
-              <a:srgbClr val="8C8C8C"/>
+              <a:srgbClr val="9A918B"/>
             </a:solidFill>
             <a:prstDash val="solid"/>
           </a:ln>
@@ -9382,7 +9667,7 @@
       </p:sp>
       <p:sp>
         <p:nvSpPr>
-          <p:cNvPr id="38" name="task-bg-174"/>
+          <p:cNvPr id="38" name="task-bg-183"/>
           <p:cNvSpPr/>
           <p:nvPr/>
         </p:nvSpPr>
@@ -9395,11 +9680,11 @@
             <a:avLst/>
           </a:prstGeom>
           <a:solidFill>
-            <a:srgbClr val="F2F2F2"/>
+            <a:srgbClr val="F6F2EF"/>
           </a:solidFill>
           <a:ln w="12700">
             <a:solidFill>
-              <a:srgbClr val="F2F2F2"/>
+              <a:srgbClr val="F6F2EF"/>
             </a:solidFill>
             <a:prstDash val="solid"/>
           </a:ln>
@@ -9407,7 +9692,7 @@
       </p:sp>
       <p:sp>
         <p:nvSpPr>
-          <p:cNvPr id="39" name="t-175"/>
+          <p:cNvPr id="39" name="t-184"/>
           <p:cNvSpPr txBox="1"/>
           <p:nvPr/>
         </p:nvSpPr>
@@ -9443,7 +9728,7 @@
       </p:sp>
       <p:sp>
         <p:nvSpPr>
-          <p:cNvPr id="40" name="t-176"/>
+          <p:cNvPr id="40" name="t-185"/>
           <p:cNvSpPr txBox="1"/>
           <p:nvPr/>
         </p:nvSpPr>
@@ -9479,7 +9764,7 @@
       </p:sp>
       <p:sp>
         <p:nvSpPr>
-          <p:cNvPr id="41" name="t-177"/>
+          <p:cNvPr id="41" name="t-186"/>
           <p:cNvSpPr txBox="1"/>
           <p:nvPr/>
         </p:nvSpPr>
@@ -9515,7 +9800,7 @@
       </p:sp>
       <p:sp>
         <p:nvSpPr>
-          <p:cNvPr id="42" name="rule-178"/>
+          <p:cNvPr id="42" name="rule-187"/>
           <p:cNvSpPr/>
           <p:nvPr/>
         </p:nvSpPr>
@@ -9530,7 +9815,7 @@
           <a:noFill/>
           <a:ln w="9525">
             <a:solidFill>
-              <a:srgbClr val="8C8C8C"/>
+              <a:srgbClr val="9A918B"/>
             </a:solidFill>
             <a:prstDash val="solid"/>
           </a:ln>
@@ -9590,47 +9875,47 @@
 </file>
 
 <file path=ppt/theme/theme1.xml><?xml version="1.0" encoding="utf-8"?>
-<a:theme xmlns:a="http://schemas.openxmlformats.org/drawingml/2006/main" name="Kanda Monthly">
+<a:theme xmlns:a="http://schemas.openxmlformats.org/drawingml/2006/main" name="Kanda Terracotta">
   <a:themeElements>
-    <a:clrScheme name="Kanda Monthly">
+    <a:clrScheme name="Kanda Terracotta">
       <a:dk1>
-        <a:srgbClr val="262626"/>
+        <a:srgbClr val="3A3A3A"/>
       </a:dk1>
       <a:lt1>
         <a:srgbClr val="FFFFFF"/>
       </a:lt1>
       <a:dk2>
-        <a:srgbClr val="595959"/>
+        <a:srgbClr val="6B6460"/>
       </a:dk2>
       <a:lt2>
-        <a:srgbClr val="F3F5F4"/>
+        <a:srgbClr val="F6F2EF"/>
       </a:lt2>
       <a:accent1>
-        <a:srgbClr val="2F5D50"/>
+        <a:srgbClr val="B5532F"/>
       </a:accent1>
       <a:accent2>
-        <a:srgbClr val="BFBFBF"/>
+        <a:srgbClr val="C9BFB8"/>
       </a:accent2>
       <a:accent3>
-        <a:srgbClr val="B23A3A"/>
+        <a:srgbClr val="2F6B4F"/>
       </a:accent3>
       <a:accent4>
-        <a:srgbClr val="E6EEEB"/>
+        <a:srgbClr val="FBEDE6"/>
       </a:accent4>
       <a:accent5>
-        <a:srgbClr val="8C8C8C"/>
+        <a:srgbClr val="9A918B"/>
       </a:accent5>
       <a:accent6>
-        <a:srgbClr val="D9D9D9"/>
+        <a:srgbClr val="E3DCD6"/>
       </a:accent6>
       <a:hlink>
-        <a:srgbClr val="2F5D50"/>
+        <a:srgbClr val="B5532F"/>
       </a:hlink>
       <a:folHlink>
-        <a:srgbClr val="595959"/>
+        <a:srgbClr val="6B6460"/>
       </a:folHlink>
     </a:clrScheme>
-    <a:fontScheme name="Kanda Monthly">
+    <a:fontScheme name="Kanda Terracotta">
       <a:majorFont>
         <a:latin typeface="Meiryo"/>
         <a:ea typeface=""/>

</xml_diff>